<commit_message>
:pencil: Final edit lect 4
</commit_message>
<xml_diff>
--- a/lessons/lesson04_model_validation/theory/slides/Lecture4 - Model Improvement, Validation, and Interpretation.pptx
+++ b/lessons/lesson04_model_validation/theory/slides/Lecture4 - Model Improvement, Validation, and Interpretation.pptx
@@ -16015,7 +16015,7 @@
                 <a:ea typeface="Calibri" pitchFamily="34" charset="-122"/>
                 <a:cs typeface="Calibri" pitchFamily="34" charset="-120"/>
               </a:rPr>
-              <a:t>SHAP attributes each prediction to its features — a consistent, per-patient explanation.</a:t>
+              <a:t>SHAP attributes each prediction to its features: a consistent, per-patient explanation.</a:t>
             </a:r>
             <a:endParaRPr lang="en-US" sz="1500" dirty="0"/>
           </a:p>
@@ -16059,7 +16059,6 @@
               </a:rPr>
               <a:t>Limit: it explains the model, not the biology: a faithful explanation of a flawed model is still flawed.</a:t>
             </a:r>
-            <a:endParaRPr lang="en-US" sz="1500" dirty="0"/>
           </a:p>
           <a:p>
             <a:pPr marL="203200" indent="-203200">
@@ -16070,6 +16069,26 @@
               <a:buChar char="•"/>
             </a:pPr>
             <a:r>
+              <a:rPr lang="en-US" sz="1500" dirty="0">
+                <a:solidFill>
+                  <a:srgbClr val="C2772B"/>
+                </a:solidFill>
+                <a:latin typeface="Calibri" pitchFamily="34" charset="0"/>
+                <a:cs typeface="Calibri" pitchFamily="34" charset="-120"/>
+              </a:rPr>
+              <a:t>Limit: correlated features get split contribution</a:t>
+            </a:r>
+            <a:endParaRPr lang="en-US" sz="1500" dirty="0"/>
+          </a:p>
+          <a:p>
+            <a:pPr marL="203200" indent="-203200">
+              <a:spcAft>
+                <a:spcPts val="1200"/>
+              </a:spcAft>
+              <a:buSzPct val="100000"/>
+              <a:buChar char="•"/>
+            </a:pPr>
+            <a:r>
               <a:rPr lang="en-US" sz="1500" b="1" dirty="0">
                 <a:solidFill>
                   <a:srgbClr val="A8403A"/>
@@ -16111,45 +16130,6 @@
           <a:lstStyle/>
           <a:p>
             <a:endParaRPr lang="en-IT"/>
-          </a:p>
-        </p:txBody>
-      </p:sp>
-      <p:sp>
-        <p:nvSpPr>
-          <p:cNvPr id="9" name="Text 6"/>
-          <p:cNvSpPr/>
-          <p:nvPr/>
-        </p:nvSpPr>
-        <p:spPr>
-          <a:xfrm>
-            <a:off x="7040880" y="2240280"/>
-            <a:ext cx="3840480" cy="274320"/>
-          </a:xfrm>
-          <a:prstGeom prst="rect">
-            <a:avLst/>
-          </a:prstGeom>
-          <a:noFill/>
-          <a:ln/>
-        </p:spPr>
-        <p:txBody>
-          <a:bodyPr wrap="square" lIns="0" tIns="0" rIns="0" bIns="0" rtlCol="0" anchor="ctr"/>
-          <a:lstStyle/>
-          <a:p>
-            <a:pPr marL="0" indent="0" algn="ctr">
-              <a:buNone/>
-            </a:pPr>
-            <a:r>
-              <a:rPr lang="en-US" sz="900" dirty="0">
-                <a:solidFill>
-                  <a:srgbClr val="5B6B70"/>
-                </a:solidFill>
-                <a:latin typeface="Calibri" pitchFamily="34" charset="0"/>
-                <a:ea typeface="Calibri" pitchFamily="34" charset="-122"/>
-                <a:cs typeface="Calibri" pitchFamily="34" charset="-120"/>
-              </a:rPr>
-              <a:t>base → prediction</a:t>
-            </a:r>
-            <a:endParaRPr lang="en-US" sz="900" dirty="0"/>
           </a:p>
         </p:txBody>
       </p:sp>

</xml_diff>

<commit_message>
:pencil: Small fix lecture 4
</commit_message>
<xml_diff>
--- a/lessons/lesson04_model_validation/theory/slides/Lecture4 - Model Improvement, Validation, and Interpretation.pptx
+++ b/lessons/lesson04_model_validation/theory/slides/Lecture4 - Model Improvement, Validation, and Interpretation.pptx
@@ -844,7 +844,7 @@
           <a:p>
             <a:r>
               <a:rPr lang="en-US" dirty="0"/>
-              <a:t>1 min. Frame the tension: students want fancier models; we'll honour that, but the lesson is that proving a model is better is harder than building a fancier one. A better algorithm is the easy part; a trustworthy estimate is the hard part.</a:t>
+              <a:t>We keep features and improve models, how to check model performance and different interpretation levels for different models</a:t>
             </a:r>
           </a:p>
         </p:txBody>
@@ -931,7 +931,41 @@
           <a:p>
             <a:r>
               <a:rPr lang="en-US" dirty="0"/>
-              <a:t>4 min. Parameters are learned FROM data during fitting (gene coefficients). Hyperparameters are set BEFORE fitting and control the model (depth, #trees, penalty C). You don't learn hyperparameters by fitting -- you search and must validate honestly.</a:t>
+              <a:t>Now the fitting vs tuning part. ML is a function with parameters you find the values of parameters to get a function such that given the input, the output of the function fits well the labels in the train data. 1 -&gt; 2 -&gt; 3 -&gt; 4.</a:t>
+            </a:r>
+            <a:br>
+              <a:rPr lang="en-US" dirty="0"/>
+            </a:br>
+            <a:br>
+              <a:rPr lang="en-US" dirty="0"/>
+            </a:br>
+            <a:r>
+              <a:rPr lang="en-US" dirty="0"/>
+              <a:t>The way you can do it: train, </a:t>
+            </a:r>
+            <a:r>
+              <a:rPr lang="en-US" dirty="0" err="1"/>
+              <a:t>val</a:t>
+            </a:r>
+            <a:r>
+              <a:rPr lang="en-US" dirty="0"/>
+              <a:t>, test -&gt; train and </a:t>
+            </a:r>
+            <a:r>
+              <a:rPr lang="en-US" dirty="0" err="1"/>
+              <a:t>val</a:t>
+            </a:r>
+            <a:r>
+              <a:rPr lang="en-US" dirty="0"/>
+              <a:t> used for hyper params tuning -&gt; test as </a:t>
+            </a:r>
+            <a:r>
+              <a:rPr lang="en-US" dirty="0" err="1"/>
+              <a:t>ext</a:t>
+            </a:r>
+            <a:r>
+              <a:rPr lang="en-US" dirty="0"/>
+              <a:t> validation -&gt; overfit tuning as we will see</a:t>
             </a:r>
           </a:p>
         </p:txBody>
@@ -1018,7 +1052,29 @@
           <a:p>
             <a:r>
               <a:rPr lang="en-US" dirty="0"/>
-              <a:t>5 min. Grid: every combination -- thorough but expensive. Random: sampled combinations -- often finds good values far cheaper. Every candidate scored by CV, never the test set. Cost explodes with #hyperparameters.</a:t>
+              <a:t>How to tune: different strategy_</a:t>
+            </a:r>
+          </a:p>
+          <a:p>
+            <a:r>
+              <a:rPr lang="en-US" dirty="0"/>
+              <a:t>1 -&gt; 2 (because very often model perform depends on few </a:t>
+            </a:r>
+            <a:r>
+              <a:rPr lang="en-US" dirty="0" err="1"/>
+              <a:t>hyperparams</a:t>
+            </a:r>
+            <a:r>
+              <a:rPr lang="en-US" dirty="0"/>
+              <a:t> -&gt; you waste a lot of resources on the ones that do not change with grid search) -&gt;3  cross </a:t>
+            </a:r>
+            <a:r>
+              <a:rPr lang="en-US" dirty="0" err="1"/>
+              <a:t>val</a:t>
+            </a:r>
+            <a:r>
+              <a:rPr lang="en-US" dirty="0"/>
+              <a:t> (with caution) -&gt; 4</a:t>
             </a:r>
           </a:p>
         </p:txBody>
@@ -1086,7 +1142,21 @@
             <p:ph type="sldImg"/>
           </p:nvPr>
         </p:nvSpPr>
-        <p:spPr/>
+        <p:spPr>
+          <a:xfrm>
+            <a:off x="-228600" y="1524000"/>
+            <a:ext cx="7315200" cy="4114800"/>
+          </a:xfrm>
+          <a:prstGeom prst="rect">
+            <a:avLst/>
+          </a:prstGeom>
+          <a:noFill/>
+          <a:ln w="12700">
+            <a:solidFill>
+              <a:prstClr val="black"/>
+            </a:solidFill>
+          </a:ln>
+        </p:spPr>
       </p:sp>
       <p:sp>
         <p:nvSpPr>
@@ -1098,45 +1168,30 @@
             <p:ph type="body" idx="1"/>
           </p:nvPr>
         </p:nvSpPr>
-        <p:spPr/>
-        <p:txBody>
-          <a:bodyPr/>
-          <a:lstStyle/>
-          <a:p>
-            <a:r>
-              <a:rPr lang="en-US" dirty="0"/>
-              <a:t>4 min. Every time you tune to the validation score, you use up its honesty. Tune hard enough and the score becomes optimistic -- you overfit the TUNING. The model never saw test data, yet the ESTIMATE is inflated. Fix is structural: nested CV.</a:t>
-            </a:r>
-          </a:p>
-        </p:txBody>
-      </p:sp>
-      <p:sp>
-        <p:nvSpPr>
-          <p:cNvPr id="4" name="Slide Number Placeholder 3"/>
-          <p:cNvSpPr>
-            <a:spLocks noGrp="1"/>
-          </p:cNvSpPr>
-          <p:nvPr>
-            <p:ph type="sldNum" sz="quarter" idx="10"/>
-          </p:nvPr>
-        </p:nvSpPr>
-        <p:spPr/>
-        <p:txBody>
-          <a:bodyPr/>
-          <a:lstStyle/>
-          <a:p>
-            <a:fld id="{F7021451-1387-4CA6-816F-3879F97B5CBC}" type="slidenum">
-              <a:rPr lang="en-US"/>
-              <a:t>13</a:t>
-            </a:fld>
-            <a:endParaRPr lang="en-US"/>
+        <p:spPr>
+          <a:xfrm>
+            <a:off x="685800" y="5867400"/>
+            <a:ext cx="5486400" cy="4800600"/>
+          </a:xfrm>
+          <a:prstGeom prst="rect">
+            <a:avLst/>
+          </a:prstGeom>
+        </p:spPr>
+        <p:txBody>
+          <a:bodyPr/>
+          <a:lstStyle/>
+          <a:p>
+            <a:r>
+              <a:rPr lang="en-IT" dirty="0"/>
+              <a:t>Follow the slide</a:t>
+            </a:r>
           </a:p>
         </p:txBody>
       </p:sp>
     </p:spTree>
     <p:extLst>
       <p:ext uri="{BB962C8B-B14F-4D97-AF65-F5344CB8AC3E}">
-        <p14:creationId xmlns:p14="http://schemas.microsoft.com/office/powerpoint/2010/main" val="1024086991"/>
+        <p14:creationId xmlns:p14="http://schemas.microsoft.com/office/powerpoint/2010/main" val="2389845536"/>
       </p:ext>
     </p:extLst>
   </p:cSld>
@@ -1192,7 +1247,7 @@
           <a:p>
             <a:r>
               <a:rPr lang="en-US" dirty="0"/>
-              <a:t>4 min. k-fold rotates the held-out fold and averages. Everything data-dependent refits inside each fold. This estimates a FIXED modelling choice. But what if the choice (hyperparameters) was selected using the data?</a:t>
+              <a:t>The danger in tuning, </a:t>
             </a:r>
           </a:p>
         </p:txBody>
@@ -1214,7 +1269,7 @@
           <a:p>
             <a:fld id="{F7021451-1387-4CA6-816F-3879F97B5CBC}" type="slidenum">
               <a:rPr lang="en-US"/>
-              <a:t>14</a:t>
+              <a:t>13</a:t>
             </a:fld>
             <a:endParaRPr lang="en-US"/>
           </a:p>
@@ -1279,7 +1334,15 @@
           <a:p>
             <a:r>
               <a:rPr lang="en-US" dirty="0"/>
-              <a:t>5 min. Two loops: inner selects hyperparameters; outer estimates performance. The outer fold is never used to choose anything. Result: an honest estimate that INCLUDES the cost of tuning. Expensive but correct.</a:t>
+              <a:t>Cross validation review: 1 -&gt; 2 -&gt; 3 -&gt;4 ( this uses up the cross </a:t>
+            </a:r>
+            <a:r>
+              <a:rPr lang="en-US" dirty="0" err="1"/>
+              <a:t>val</a:t>
+            </a:r>
+            <a:r>
+              <a:rPr lang="en-US" dirty="0"/>
+              <a:t>) -&gt; optimistic estimates!</a:t>
             </a:r>
           </a:p>
         </p:txBody>
@@ -1301,7 +1364,7 @@
           <a:p>
             <a:fld id="{F7021451-1387-4CA6-816F-3879F97B5CBC}" type="slidenum">
               <a:rPr lang="en-US"/>
-              <a:t>15</a:t>
+              <a:t>14</a:t>
             </a:fld>
             <a:endParaRPr lang="en-US"/>
           </a:p>
@@ -1366,7 +1429,7 @@
           <a:p>
             <a:r>
               <a:rPr lang="en-US" dirty="0"/>
-              <a:t>4 min. Without it, tuned models report optimistic scores that don't replicate -- worst at small n, many hyperparameters, flexible models. Rule: if you tuned on it, you can't also report performance on it. Measured in the practical.</a:t>
+              <a:t>Solution is nested cross validation. 1 -&gt; 2 -&gt; example on the right -&gt; 3 -&gt; 4 -&gt; 5</a:t>
             </a:r>
           </a:p>
         </p:txBody>
@@ -1388,7 +1451,7 @@
           <a:p>
             <a:fld id="{F7021451-1387-4CA6-816F-3879F97B5CBC}" type="slidenum">
               <a:rPr lang="en-US"/>
-              <a:t>16</a:t>
+              <a:t>15</a:t>
             </a:fld>
             <a:endParaRPr lang="en-US"/>
           </a:p>
@@ -1453,7 +1516,7 @@
           <a:p>
             <a:r>
               <a:rPr lang="en-US" dirty="0"/>
-              <a:t>5 min. A model can look great in-cohort and collapse on independent data. Usual culprit: technical variation between cohorts -- batch effects. Our setting: METABRIC (Illumina) vs GSE6532 (Affymetrix). Cross-cohort validation is the closest thing to truth.</a:t>
+              <a:t>Read slide</a:t>
             </a:r>
           </a:p>
         </p:txBody>
@@ -1475,7 +1538,7 @@
           <a:p>
             <a:fld id="{F7021451-1387-4CA6-816F-3879F97B5CBC}" type="slidenum">
               <a:rPr lang="en-US"/>
-              <a:t>17</a:t>
+              <a:t>16</a:t>
             </a:fld>
             <a:endParaRPr lang="en-US"/>
           </a:p>
@@ -1540,7 +1603,7 @@
           <a:p>
             <a:r>
               <a:rPr lang="en-US" dirty="0"/>
-              <a:t>5 min. ComBat/RUV estimate and subtract batch effects -&gt; cohorts become comparable. Risk: aggressive correction removes real biology, or done wrong leaks the outcome. Pathway features (L3) are a gentler, more platform-robust alternative.</a:t>
+              <a:t>Now let’s move to the reason why models fail on new cohorts. This will happen -&gt; 1 -&gt; 2 it’s possible that the model is good but data different (different scale, different norm) -&gt; figure -&gt; 3 out setting -&gt; we expect different scales -&gt; 4 </a:t>
             </a:r>
           </a:p>
         </p:txBody>
@@ -1562,7 +1625,7 @@
           <a:p>
             <a:fld id="{F7021451-1387-4CA6-816F-3879F97B5CBC}" type="slidenum">
               <a:rPr lang="en-US"/>
-              <a:t>18</a:t>
+              <a:t>17</a:t>
             </a:fld>
             <a:endParaRPr lang="en-US"/>
           </a:p>
@@ -1627,7 +1690,7 @@
           <a:p>
             <a:r>
               <a:rPr lang="en-US" dirty="0"/>
-              <a:t>5 min. Cardinal rule: correction must not use the outcome and must respect the split. Estimate on train, apply same transform to held-out. Correcting everything together is leakage. If batch is perfectly confounded with outcome, no method can rescue it.</a:t>
+              <a:t>How to correct for batch? Title -&gt; 1 -&gt; 2 -&gt; 3 (answer: some information just align with batch and these might be important) -&gt; 4</a:t>
             </a:r>
           </a:p>
         </p:txBody>
@@ -1649,7 +1712,7 @@
           <a:p>
             <a:fld id="{F7021451-1387-4CA6-816F-3879F97B5CBC}" type="slidenum">
               <a:rPr lang="en-US"/>
-              <a:t>19</a:t>
+              <a:t>18</a:t>
             </a:fld>
             <a:endParaRPr lang="en-US"/>
           </a:p>
@@ -1714,7 +1777,7 @@
           <a:p>
             <a:r>
               <a:rPr lang="en-US" dirty="0"/>
-              <a:t>4 min. Coefficients: direction+magnitude but scale/correlation-dependent. RF importance: biased, unstable. Correlated genes share/split importance. Always check stability across folds before believing a ranking.</a:t>
+              <a:t>READ the slide</a:t>
             </a:r>
           </a:p>
         </p:txBody>
@@ -1736,7 +1799,7 @@
           <a:p>
             <a:fld id="{F7021451-1387-4CA6-816F-3879F97B5CBC}" type="slidenum">
               <a:rPr lang="en-US"/>
-              <a:t>20</a:t>
+              <a:t>19</a:t>
             </a:fld>
             <a:endParaRPr lang="en-US"/>
           </a:p>
@@ -1801,7 +1864,7 @@
           <a:p>
             <a:r>
               <a:rPr lang="en-US" dirty="0"/>
-              <a:t>2 min. Trustworthy problem (L1), model (L2), features (L3). You can build a biologically-informed baseline and you want to make it fancier. Today: more powerful families, proper tuning, and the validation that keeps them honest. Resist: 'more complex = better'.</a:t>
+              <a:t>To recap: 1 -&gt; 2 -&gt; 3 </a:t>
             </a:r>
           </a:p>
         </p:txBody>
@@ -1887,9 +1950,20 @@
           <a:lstStyle/>
           <a:p>
             <a:r>
+              <a:rPr lang="en-US" dirty="0" err="1"/>
+              <a:t>Interpreatation</a:t>
+            </a:r>
+            <a:r>
               <a:rPr lang="en-US" dirty="0"/>
-              <a:t>4 min. SHAP attributes each prediction to its features -- a consistent per-patient explanation. Useful: shows HOW the model decided for an individual tumour. Limit: explains the MODEL, not the biology. Never present SHAP as mechanism/causation.</a:t>
-            </a:r>
+              <a:t> is important. 1-&gt; 2 -&gt; 3 -&gt; 4</a:t>
+            </a:r>
+            <a:r>
+              <a:rPr lang="en-US" dirty="0">
+                <a:sym typeface="Wingdings" pitchFamily="2" charset="2"/>
+              </a:rPr>
+              <a:t> 5 -&gt;6</a:t>
+            </a:r>
+            <a:endParaRPr lang="en-US" dirty="0"/>
           </a:p>
         </p:txBody>
       </p:sp>
@@ -1910,7 +1984,7 @@
           <a:p>
             <a:fld id="{F7021451-1387-4CA6-816F-3879F97B5CBC}" type="slidenum">
               <a:rPr lang="en-US"/>
-              <a:t>21</a:t>
+              <a:t>20</a:t>
             </a:fld>
             <a:endParaRPr lang="en-US"/>
           </a:p>
@@ -1975,7 +2049,15 @@
           <a:p>
             <a:r>
               <a:rPr lang="en-US" dirty="0"/>
-              <a:t>4 min. Random seeds: fix &amp; report. Pipelines: encapsulate preprocessing+model so it refits inside CV. Version control + environment capture. Notebook organisation &amp; experiment tracking: every number regenerable.</a:t>
+              <a:t>When a model does not give you the importance score -&gt; use </a:t>
+            </a:r>
+            <a:r>
+              <a:rPr lang="en-US" dirty="0" err="1"/>
+              <a:t>shap</a:t>
+            </a:r>
+            <a:r>
+              <a:rPr lang="en-US" dirty="0"/>
+              <a:t> -&gt; 1 -&gt; 2 -&gt; 3 -&gt; 4 -&gt; 5</a:t>
             </a:r>
           </a:p>
         </p:txBody>
@@ -1997,7 +2079,7 @@
           <a:p>
             <a:fld id="{F7021451-1387-4CA6-816F-3879F97B5CBC}" type="slidenum">
               <a:rPr lang="en-US"/>
-              <a:t>22</a:t>
+              <a:t>21</a:t>
             </a:fld>
             <a:endParaRPr lang="en-US"/>
           </a:p>
@@ -2060,10 +2142,7 @@
           <a:bodyPr/>
           <a:lstStyle/>
           <a:p>
-            <a:r>
-              <a:rPr lang="en-US" dirty="0"/>
-              <a:t>4 min. Not the most complex, not the highest training score. The best model is robust, interpretable, reproducible, well-validated. Prefer the simplest model whose advantage survives honest (nested, cross-cohort) validation.</a:t>
-            </a:r>
+            <a:endParaRPr lang="en-US" dirty="0"/>
           </a:p>
         </p:txBody>
       </p:sp>
@@ -2084,7 +2163,7 @@
           <a:p>
             <a:fld id="{F7021451-1387-4CA6-816F-3879F97B5CBC}" type="slidenum">
               <a:rPr lang="en-US"/>
-              <a:t>23</a:t>
+              <a:t>22</a:t>
             </a:fld>
             <a:endParaRPr lang="en-US"/>
           </a:p>
@@ -2149,7 +2228,7 @@
           <a:p>
             <a:r>
               <a:rPr lang="en-US" dirty="0"/>
-              <a:t>2 min. Deliver the thesis. Three corollaries: gains are smaller than expected; validation errors do more damage than model choice; plausibility is not causation. This is where students graduate from building models to judging them.</a:t>
+              <a:t>1 -&gt; 2 -&gt; 3 -&gt; 4</a:t>
             </a:r>
           </a:p>
         </p:txBody>
@@ -2171,7 +2250,7 @@
           <a:p>
             <a:fld id="{F7021451-1387-4CA6-816F-3879F97B5CBC}" type="slidenum">
               <a:rPr lang="en-US"/>
-              <a:t>24</a:t>
+              <a:t>23</a:t>
             </a:fld>
             <a:endParaRPr lang="en-US"/>
           </a:p>
@@ -2234,10 +2313,7 @@
           <a:bodyPr/>
           <a:lstStyle/>
           <a:p>
-            <a:r>
-              <a:rPr lang="en-US" dirty="0"/>
-              <a:t>2 min. Tick objectives. Practical: compare LR/RF/GBM on the same features; tune one with grid/random search; estimate honestly with nested CV; batch-correction experiment (METABRIC-&gt;GSE6532, with/without); interpret importances responsibly; choose a model for publication. Next: research-grade ML -- survival models, external validation at scale.</a:t>
-            </a:r>
+            <a:endParaRPr lang="en-US" dirty="0"/>
           </a:p>
         </p:txBody>
       </p:sp>
@@ -2258,7 +2334,7 @@
           <a:p>
             <a:fld id="{F7021451-1387-4CA6-816F-3879F97B5CBC}" type="slidenum">
               <a:rPr lang="en-US"/>
-              <a:t>25</a:t>
+              <a:t>24</a:t>
             </a:fld>
             <a:endParaRPr lang="en-US"/>
           </a:p>
@@ -2278,6 +2354,93 @@
 </file>
 
 <file path=ppt/notesSlides/notesSlide25.xml><?xml version="1.0" encoding="utf-8"?>
+<p:notes xmlns:a="http://schemas.openxmlformats.org/drawingml/2006/main" xmlns:r="http://schemas.openxmlformats.org/officeDocument/2006/relationships" xmlns:p="http://schemas.openxmlformats.org/presentationml/2006/main">
+  <p:cSld>
+    <p:spTree>
+      <p:nvGrpSpPr>
+        <p:cNvPr id="1" name=""/>
+        <p:cNvGrpSpPr/>
+        <p:nvPr/>
+      </p:nvGrpSpPr>
+      <p:grpSpPr>
+        <a:xfrm>
+          <a:off x="0" y="0"/>
+          <a:ext cx="0" cy="0"/>
+          <a:chOff x="0" y="0"/>
+          <a:chExt cx="0" cy="0"/>
+        </a:xfrm>
+      </p:grpSpPr>
+      <p:sp>
+        <p:nvSpPr>
+          <p:cNvPr id="2" name="Slide Image Placeholder 1"/>
+          <p:cNvSpPr>
+            <a:spLocks noGrp="1" noRot="1" noChangeAspect="1"/>
+          </p:cNvSpPr>
+          <p:nvPr>
+            <p:ph type="sldImg"/>
+          </p:nvPr>
+        </p:nvSpPr>
+        <p:spPr/>
+      </p:sp>
+      <p:sp>
+        <p:nvSpPr>
+          <p:cNvPr id="3" name="Notes Placeholder 2"/>
+          <p:cNvSpPr>
+            <a:spLocks noGrp="1"/>
+          </p:cNvSpPr>
+          <p:nvPr>
+            <p:ph type="body" idx="1"/>
+          </p:nvPr>
+        </p:nvSpPr>
+        <p:spPr/>
+        <p:txBody>
+          <a:bodyPr/>
+          <a:lstStyle/>
+          <a:p>
+            <a:r>
+              <a:rPr lang="en-US" dirty="0"/>
+              <a:t>2 min. Tick objectives. Practical: compare LR/RF/GBM on the same features; tune one with grid/random search; estimate honestly with nested CV; batch-correction experiment (METABRIC-&gt;GSE6532, with/without); interpret importances responsibly; choose a model for publication. Next: research-grade ML -- survival models, external validation at scale.</a:t>
+            </a:r>
+          </a:p>
+        </p:txBody>
+      </p:sp>
+      <p:sp>
+        <p:nvSpPr>
+          <p:cNvPr id="4" name="Slide Number Placeholder 3"/>
+          <p:cNvSpPr>
+            <a:spLocks noGrp="1"/>
+          </p:cNvSpPr>
+          <p:nvPr>
+            <p:ph type="sldNum" sz="quarter" idx="10"/>
+          </p:nvPr>
+        </p:nvSpPr>
+        <p:spPr/>
+        <p:txBody>
+          <a:bodyPr/>
+          <a:lstStyle/>
+          <a:p>
+            <a:fld id="{F7021451-1387-4CA6-816F-3879F97B5CBC}" type="slidenum">
+              <a:rPr lang="en-US"/>
+              <a:t>25</a:t>
+            </a:fld>
+            <a:endParaRPr lang="en-US"/>
+          </a:p>
+        </p:txBody>
+      </p:sp>
+    </p:spTree>
+    <p:extLst>
+      <p:ext uri="{BB962C8B-B14F-4D97-AF65-F5344CB8AC3E}">
+        <p14:creationId xmlns:p14="http://schemas.microsoft.com/office/powerpoint/2010/main" val="1024086991"/>
+      </p:ext>
+    </p:extLst>
+  </p:cSld>
+  <p:clrMapOvr>
+    <a:masterClrMapping/>
+  </p:clrMapOvr>
+</p:notes>
+</file>
+
+<file path=ppt/notesSlides/notesSlide26.xml><?xml version="1.0" encoding="utf-8"?>
 <p:notes xmlns:a="http://schemas.openxmlformats.org/drawingml/2006/main" xmlns:r="http://schemas.openxmlformats.org/officeDocument/2006/relationships" xmlns:p="http://schemas.openxmlformats.org/presentationml/2006/main">
   <p:cSld>
     <p:spTree>
@@ -2434,7 +2597,7 @@
           <a:p>
             <a:r>
               <a:rPr lang="en-US" dirty="0"/>
-              <a:t>2 min. Checklist ticked as we go. The two carrying the weight: nested cross-validation (why tuning inflates estimates) and batch correction done correctly (why models fail on new cohorts).</a:t>
+              <a:t>Describe all of them. Common mistakes: wrong cross validation; wrong batch correction; data leakage and overfitting in hyper params tuning</a:t>
             </a:r>
           </a:p>
         </p:txBody>
@@ -2521,7 +2684,7 @@
           <a:p>
             <a:r>
               <a:rPr lang="en-US" dirty="0"/>
-              <a:t>4 min. You own a validated baseline. The real question isn't 'can I build something fancier?' but 'can I SHOW it's better?' A complex model must EARN its complexity with validated gain.</a:t>
+              <a:t>1 Logistic regression with regularization with biologically meaningful features, our prior knowledge and eval on cross validation  -&gt; 2 (you can always build fancier model) -&gt; 3 </a:t>
             </a:r>
           </a:p>
         </p:txBody>
@@ -2608,7 +2771,15 @@
           <a:p>
             <a:r>
               <a:rPr lang="en-US" dirty="0"/>
-              <a:t>4 min. Compare on the same split/metrics/validation -- change only the model. A difference within CV noise is NOT an improvement. Prefer the simpler model unless the gain is real, validated, meaningful.</a:t>
+              <a:t>Title -&gt; 1 (this is the rule actually in every field) -&gt; 2 -&gt; comment figure (average is higher in B, but cross </a:t>
+            </a:r>
+            <a:r>
+              <a:rPr lang="en-US" dirty="0" err="1"/>
+              <a:t>val</a:t>
+            </a:r>
+            <a:r>
+              <a:rPr lang="en-US" dirty="0"/>
+              <a:t> CV overlap) -&gt; 3</a:t>
             </a:r>
           </a:p>
         </p:txBody>
@@ -2695,7 +2866,15 @@
           <a:p>
             <a:r>
               <a:rPr lang="en-US" dirty="0"/>
-              <a:t>5 min. A tree is a cascade of yes/no biological rules -- reads like clinical decision-making, very interpretable for ONE tree. But single trees are unstable (resample -&gt; different tree) and overfit without constraints.</a:t>
+              <a:t>The class of model we </a:t>
+            </a:r>
+            <a:r>
+              <a:rPr lang="en-US" dirty="0" err="1"/>
+              <a:t>wanna</a:t>
+            </a:r>
+            <a:r>
+              <a:rPr lang="en-US" dirty="0"/>
+              <a:t> describe, Tree based. First and simplest is decision tree. 1 -&gt; figure -&gt; 2 -&gt; 3 (data split change, order of questions (features)) -&gt; 3 </a:t>
             </a:r>
           </a:p>
         </p:txBody>
@@ -2782,7 +2961,13 @@
           <a:p>
             <a:r>
               <a:rPr lang="en-US" dirty="0"/>
-              <a:t>5 min. Many trees on resampled data/features, voting. Averaging unstable trees -&gt; robust, lower-variance predictor. Free (caveated) importance. Limits: less interpretable, biased importances, not magic on small n.</a:t>
+              <a:t>The instability and overfitting motivates random forests. If single overfit, what about many different trees? It works</a:t>
+            </a:r>
+          </a:p>
+          <a:p>
+            <a:r>
+              <a:rPr lang="en-US" dirty="0"/>
+              <a:t>1 -&gt; 2 (answer to the question: errors are independent and when averaging, they cancel out, while signal stays) -&gt; 3 (importance is the sum of all decrease in impurity across trees) -&gt; 4</a:t>
             </a:r>
           </a:p>
         </p:txBody>
@@ -2869,7 +3054,7 @@
           <a:p>
             <a:r>
               <a:rPr lang="en-US" dirty="0"/>
-              <a:t>5 min. Trees built sequentially, each correcting the last's mistakes. Often the strongest tabular predictor -- but the easiest to overfit and most tuning-sensitive. In p&gt;&gt;n with modest signal, its edge over a good baseline is often small.</a:t>
+              <a:t>Contrast between RF and GB: 1 -&gt; 2 -&gt; 3 (wins but not generalizable because we overfit the tuning)</a:t>
             </a:r>
           </a:p>
         </p:txBody>
@@ -2956,7 +3141,7 @@
           <a:p>
             <a:r>
               <a:rPr lang="en-US" dirty="0"/>
-              <a:t>4 min. Linear: interpretable, stable, strong in p&gt;&gt;n -- the default. RF: robust, low-tuning, weaker interpretability. GBM: highest ceiling, highest overfitting risk. Honest expectation: complex models rarely beat a good baseline by much here.</a:t>
+              <a:t>R LR ok -&gt; RF (interpretability less than LR, but it is interpretable. One often takes RF across CV and do GO) -&gt; </a:t>
             </a:r>
           </a:p>
         </p:txBody>
@@ -6416,7 +6601,7 @@
           <p:nvPr/>
         </p:nvPicPr>
         <p:blipFill>
-          <a:blip r:embed="rId2"/>
+          <a:blip r:embed="rId3"/>
           <a:stretch>
             <a:fillRect/>
           </a:stretch>
@@ -15110,7 +15295,7 @@
                 <a:ea typeface="Calibri" pitchFamily="34" charset="-122"/>
                 <a:cs typeface="Calibri" pitchFamily="34" charset="-120"/>
               </a:rPr>
-              <a:t>Three interpretation tools: linear coefficients, tree-based importance, SHAP values.</a:t>
+              <a:t>Three interpretation tools: linear coefficients, tree-based importance, SHAP values (next slide).</a:t>
             </a:r>
             <a:endParaRPr lang="en-US" sz="1500" dirty="0">
               <a:solidFill>
@@ -22769,7 +22954,7 @@
                 <a:ea typeface="Calibri" pitchFamily="34" charset="-122"/>
                 <a:cs typeface="Calibri" pitchFamily="34" charset="-120"/>
               </a:rPr>
-              <a:t>Averaging many unstable trees → a robust, lower-variance predictor.</a:t>
+              <a:t>Averaging many unstable trees → a robust, lower-variance predictor. WHY is this?</a:t>
             </a:r>
             <a:endParaRPr lang="en-US" sz="1550" dirty="0"/>
           </a:p>
@@ -24903,7 +25088,7 @@
                 <a:ea typeface="Calibri" pitchFamily="34" charset="-122"/>
                 <a:cs typeface="Calibri" pitchFamily="34" charset="-120"/>
               </a:rPr>
-              <a:t>Small (high risk)</a:t>
+              <a:t>ok (high risk)</a:t>
             </a:r>
             <a:endParaRPr lang="en-US" sz="1200" dirty="0"/>
           </a:p>

</xml_diff>